<commit_message>
Rebuild Review 2/3 decks and report with the served CRNN numbers
</commit_message>
<xml_diff>
--- a/docs/Review2/SafeScape_Review2.pptx
+++ b/docs/Review2/SafeScape_Review2.pptx
@@ -39211,7 +39211,7 @@
       </p:sp>
       <p:pic>
         <p:nvPicPr>
-          <p:cNvPr id="6" name="Picture 5" descr="logmel_crnn_v2_leakfree_confusion_matrix.png"/>
+          <p:cNvPr id="6" name="Picture 5" descr="logmel_crnn_v2_int8_leakfree_confusion_matrix.png"/>
           <p:cNvPicPr>
             <a:picLocks noChangeAspect="1"/>
           </p:cNvPicPr>
@@ -39923,7 +39923,7 @@
                           </a:solidFill>
                           <a:latin typeface="Calibri"/>
                         </a:rPr>
-                        <a:t>0.853</a:t>
+                        <a:t>0.852</a:t>
                       </a:r>
                     </a:p>
                   </a:txBody>
@@ -39945,7 +39945,7 @@
                           </a:solidFill>
                           <a:latin typeface="Calibri"/>
                         </a:rPr>
-                        <a:t>86.5%</a:t>
+                        <a:t>86.7%</a:t>
                       </a:r>
                     </a:p>
                   </a:txBody>
@@ -40011,7 +40011,7 @@
                           </a:solidFill>
                           <a:latin typeface="Calibri"/>
                         </a:rPr>
-                        <a:t>6.90 ms</a:t>
+                        <a:t>12.81 ms</a:t>
                       </a:r>
                     </a:p>
                   </a:txBody>
@@ -40278,7 +40278,7 @@
                 </a:solidFill>
                 <a:latin typeface="Calibri"/>
               </a:rPr>
-              <a:t>▪  CRNN leads every quality metric: macro-F1 0.853 vs 0.774 / 0.725</a:t>
+              <a:t>▪  CRNN leads every quality metric: macro-F1 0.852 vs 0.774 / 0.725</a:t>
             </a:r>
           </a:p>
           <a:p>
@@ -40294,7 +40294,7 @@
                 </a:solidFill>
                 <a:latin typeface="Calibri"/>
               </a:rPr>
-              <a:t>▪  Transformer: 17% of the CRNN's parameters, 14× faster per window</a:t>
+              <a:t>▪  Transformer: 17% of the CRNN's parameters, 27× faster per window</a:t>
             </a:r>
           </a:p>
           <a:p>
@@ -40499,7 +40499,7 @@
                 </a:solidFill>
                 <a:latin typeface="Calibri"/>
               </a:rPr>
-              <a:t>python 10_evaluate.py --arch logmel_crnn --hidden-size 128 --ckpt ../models/checkpoints/logmel_crnn_v2.pt --calibration ../models/exported/logmel_crnn/calibration.json --manifest ../data/processed_v2/windows_manifest_dedup.csv --cpu-only        (Harish)</a:t>
+              <a:t>python 10_evaluate.py --arch logmel_crnn --hidden-size 128 --ckpt ../models/exported/logmel_crnn/best_model.pt --quantized --calibration ../models/exported/logmel_crnn/calibration.json --manifest ../data/processed_v2/windows_manifest_dedup.csv        (Harish)</a:t>
             </a:r>
           </a:p>
           <a:p>
@@ -43681,7 +43681,7 @@
                 </a:solidFill>
                 <a:latin typeface="Calibri"/>
               </a:rPr>
-              <a:t>Impact was small (CRNN 89.8% → 89.7%), but every headline number is now on audio no model has heard.</a:t>
+              <a:t>Impact was small (CRNN 89.8% → 89.7%), and no test window has a byte-identical copy in training (exact-match check; re-encoded copies would not be caught).</a:t>
             </a:r>
           </a:p>
         </p:txBody>
@@ -46091,7 +46091,7 @@
                           </a:solidFill>
                           <a:latin typeface="Calibri"/>
                         </a:rPr>
-                        <a:t>0.87</a:t>
+                        <a:t>0.88</a:t>
                       </a:r>
                     </a:p>
                   </a:txBody>
@@ -46137,7 +46137,7 @@
                           </a:solidFill>
                           <a:latin typeface="Calibri"/>
                         </a:rPr>
-                        <a:t>0.69</a:t>
+                        <a:t>0.68</a:t>
                       </a:r>
                     </a:p>
                   </a:txBody>
@@ -46181,7 +46181,7 @@
                           </a:solidFill>
                           <a:latin typeface="Calibri"/>
                         </a:rPr>
-                        <a:t>0.69</a:t>
+                        <a:t>0.68</a:t>
                       </a:r>
                     </a:p>
                   </a:txBody>
@@ -46532,7 +46532,7 @@
                 </a:solidFill>
                 <a:latin typeface="Calibri"/>
               </a:rPr>
-              <a:t>macro-F1 0.853</a:t>
+              <a:t>macro-F1 0.852</a:t>
             </a:r>
           </a:p>
           <a:p>
@@ -46548,7 +46548,7 @@
                 </a:solidFill>
                 <a:latin typeface="Calibri"/>
               </a:rPr>
-              <a:t>distress recall 86.5%</a:t>
+              <a:t>distress recall 86.7%</a:t>
             </a:r>
           </a:p>
           <a:p>
@@ -46580,7 +46580,7 @@
                 </a:solidFill>
                 <a:latin typeface="Calibri"/>
               </a:rPr>
-              <a:t>516 KB · 6.90 ms</a:t>
+              <a:t>516 KB · 12.81 ms</a:t>
             </a:r>
           </a:p>
         </p:txBody>

</xml_diff>

<commit_message>
Compute the report and deck figures instead of typing them
</commit_message>
<xml_diff>
--- a/docs/Review2/SafeScape_Review2.pptx
+++ b/docs/Review2/SafeScape_Review2.pptx
@@ -40483,7 +40483,7 @@
                 </a:solidFill>
                 <a:latin typeface="Calibri"/>
               </a:rPr>
-              <a:t>python 10_evaluate.py --arch mfcc_cnn --ckpt ../models/checkpoints/mfcc_cnn_v2.pt --calibration ../models/exported/mfcc_cnn/calibration.json --manifest ../data/processed_v2/windows_manifest_dedup.csv --cpu-only        (Amruth)</a:t>
+              <a:t>python 10_evaluate.py --arch mfcc_cnn --ckpt ../models/checkpoints/mfcc_cnn_v2.pt --calibration ../models/exported/mfcc_cnn/calibration.json --manifest ../data/processed_v2/windows_manifest_dedup.csv --cpu-only --no-log        (Amruth)</a:t>
             </a:r>
           </a:p>
           <a:p>
@@ -40499,7 +40499,7 @@
                 </a:solidFill>
                 <a:latin typeface="Calibri"/>
               </a:rPr>
-              <a:t>python 10_evaluate.py --arch logmel_crnn --hidden-size 128 --ckpt ../models/exported/logmel_crnn/best_model.pt --quantized --calibration ../models/exported/logmel_crnn/calibration.json --manifest ../data/processed_v2/windows_manifest_dedup.csv        (Harish)</a:t>
+              <a:t>python 10_evaluate.py --arch logmel_crnn --hidden-size 128 --ckpt ../models/exported/logmel_crnn/best_model.pt --quantized --calibration ../models/exported/logmel_crnn/calibration.json --manifest ../data/processed_v2/windows_manifest_dedup.csv --no-log        (Harish)</a:t>
             </a:r>
           </a:p>
           <a:p>
@@ -40515,7 +40515,7 @@
                 </a:solidFill>
                 <a:latin typeface="Calibri"/>
               </a:rPr>
-              <a:t>python 10_evaluate.py --arch transformer --ckpt ../models/checkpoints/transformer_v2.pt --calibration ../models/exported/transformer/calibration.json --manifest ../data/processed_v2/windows_manifest_dedup.csv --cpu-only        (Harish)</a:t>
+              <a:t>python 10_evaluate.py --arch transformer --ckpt ../models/checkpoints/transformer_v2.pt --calibration ../models/exported/transformer/calibration.json --manifest ../data/processed_v2/windows_manifest_dedup.csv --cpu-only --no-log        (Harish)</a:t>
             </a:r>
           </a:p>
           <a:p>
@@ -43681,7 +43681,7 @@
                 </a:solidFill>
                 <a:latin typeface="Calibri"/>
               </a:rPr>
-              <a:t>Impact was small (CRNN 89.8% → 89.7%), and no test window has a byte-identical copy in training (exact-match check; re-encoded copies would not be caught).</a:t>
+              <a:t>Impact was small (CRNN 89.8% on the full test set, 89.7% without them), and no test window has a byte-identical copy in training (exact-match check; re-encoded copies would not be caught).</a:t>
             </a:r>
           </a:p>
         </p:txBody>

</xml_diff>